<commit_message>
contextualize for Hyundai: plant anchors, ROI calc, architecture diagrams
- index.html + build_pptx.py: HMGICS/AIRS/Boston Dynamics callout on slide 2;
  Ulsan/Metaplant cadence on slide 3; Recommended Hyundai Start cards on UC-01
  (HMGMA IONIQ paint) and UC-06 (Ulsan stamping + Asan welding); summary slide
  anchors pilots at specific plants
- New: ROI_Calculator_Hyundai.xlsx with 4 sheets (Inputs, Pilot Sizing,
  Full Use Cases, Notes), Ulsan-scale defaults, 3-year NPV math
- New: 2 reference architecture SVGs (Visual Inspection + Predictive Maintenance)
  + PNGs, embedded as appendix slides 16 and 17 in the PPTX
- executive_brief: Hyundai AI-bets complement paragraph; pilot recommendations
  anchored at HMGMA and Ulsan/Asan
- README: full bundle map, distribution flow, ROI calculator usage guide
</commit_message>
<xml_diff>
--- a/Hyundai_PeopleTech_AI_Plant_Operations.pptx
+++ b/Hyundai_PeopleTech_AI_Plant_Operations.pptx
@@ -20,6 +20,8 @@
     <p:sldId id="268" r:id="rId19"/>
     <p:sldId id="269" r:id="rId20"/>
     <p:sldId id="270" r:id="rId21"/>
+    <p:sldId id="271" r:id="rId22"/>
+    <p:sldId id="272" r:id="rId23"/>
   </p:sldIdLst>
   <p:sldSz cx="12191695" cy="6858000" type="screen4x3"/>
   <p:notesSz cx="6858000" cy="9144000"/>
@@ -3971,7 +3973,7 @@
                 </a:solidFill>
                 <a:latin typeface="Calibri"/>
               </a:rPr>
-              <a:t>01 / 15</a:t>
+              <a:t>01 / 17</a:t>
             </a:r>
           </a:p>
         </p:txBody>
@@ -5281,7 +5283,7 @@
         <p:spPr>
           <a:xfrm>
             <a:off x="7040880" y="3246120"/>
-            <a:ext cx="4663440" cy="822960"/>
+            <a:ext cx="4663440" cy="777240"/>
           </a:xfrm>
           <a:prstGeom prst="rect">
             <a:avLst/>
@@ -5325,7 +5327,7 @@
         <p:spPr>
           <a:xfrm>
             <a:off x="7040880" y="3246120"/>
-            <a:ext cx="54864" cy="822960"/>
+            <a:ext cx="54864" cy="777240"/>
           </a:xfrm>
           <a:prstGeom prst="rect">
             <a:avLst/>
@@ -5408,7 +5410,7 @@
         <p:spPr>
           <a:xfrm>
             <a:off x="7205472" y="3538728"/>
-            <a:ext cx="4434840" cy="502920"/>
+            <a:ext cx="4434840" cy="457200"/>
           </a:xfrm>
           <a:prstGeom prst="rect">
             <a:avLst/>
@@ -5446,8 +5448,8 @@
         </p:nvSpPr>
         <p:spPr>
           <a:xfrm>
-            <a:off x="7040880" y="4160520"/>
-            <a:ext cx="4663440" cy="685800"/>
+            <a:off x="7040880" y="4114800"/>
+            <a:ext cx="4663440" cy="594360"/>
           </a:xfrm>
           <a:prstGeom prst="rect">
             <a:avLst/>
@@ -5490,8 +5492,8 @@
         </p:nvSpPr>
         <p:spPr>
           <a:xfrm>
-            <a:off x="7040880" y="4160520"/>
-            <a:ext cx="54864" cy="685800"/>
+            <a:off x="7040880" y="4114800"/>
+            <a:ext cx="54864" cy="594360"/>
           </a:xfrm>
           <a:prstGeom prst="rect">
             <a:avLst/>
@@ -5534,7 +5536,7 @@
         </p:nvSpPr>
         <p:spPr>
           <a:xfrm>
-            <a:off x="7205472" y="4233672"/>
+            <a:off x="7205472" y="4187952"/>
             <a:ext cx="4434840" cy="201168"/>
           </a:xfrm>
           <a:prstGeom prst="rect">
@@ -5573,8 +5575,8 @@
         </p:nvSpPr>
         <p:spPr>
           <a:xfrm>
-            <a:off x="7205472" y="4453128"/>
-            <a:ext cx="4434840" cy="365760"/>
+            <a:off x="7205472" y="4407408"/>
+            <a:ext cx="4434840" cy="274320"/>
           </a:xfrm>
           <a:prstGeom prst="rect">
             <a:avLst/>
@@ -6160,7 +6162,7 @@
                 </a:solidFill>
                 <a:latin typeface="Calibri"/>
               </a:rPr>
-              <a:t>10 / 15 · CONFIDENTIAL</a:t>
+              <a:t>10 / 17 · CONFIDENTIAL</a:t>
             </a:r>
           </a:p>
         </p:txBody>
@@ -7470,7 +7472,7 @@
         <p:spPr>
           <a:xfrm>
             <a:off x="7040880" y="3246120"/>
-            <a:ext cx="4663440" cy="822960"/>
+            <a:ext cx="4663440" cy="777240"/>
           </a:xfrm>
           <a:prstGeom prst="rect">
             <a:avLst/>
@@ -7514,7 +7516,7 @@
         <p:spPr>
           <a:xfrm>
             <a:off x="7040880" y="3246120"/>
-            <a:ext cx="54864" cy="822960"/>
+            <a:ext cx="54864" cy="777240"/>
           </a:xfrm>
           <a:prstGeom prst="rect">
             <a:avLst/>
@@ -7597,7 +7599,7 @@
         <p:spPr>
           <a:xfrm>
             <a:off x="7205472" y="3538728"/>
-            <a:ext cx="4434840" cy="502920"/>
+            <a:ext cx="4434840" cy="457200"/>
           </a:xfrm>
           <a:prstGeom prst="rect">
             <a:avLst/>
@@ -7635,8 +7637,8 @@
         </p:nvSpPr>
         <p:spPr>
           <a:xfrm>
-            <a:off x="7040880" y="4160520"/>
-            <a:ext cx="4663440" cy="685800"/>
+            <a:off x="7040880" y="4114800"/>
+            <a:ext cx="4663440" cy="594360"/>
           </a:xfrm>
           <a:prstGeom prst="rect">
             <a:avLst/>
@@ -7679,8 +7681,8 @@
         </p:nvSpPr>
         <p:spPr>
           <a:xfrm>
-            <a:off x="7040880" y="4160520"/>
-            <a:ext cx="54864" cy="685800"/>
+            <a:off x="7040880" y="4114800"/>
+            <a:ext cx="54864" cy="594360"/>
           </a:xfrm>
           <a:prstGeom prst="rect">
             <a:avLst/>
@@ -7723,7 +7725,7 @@
         </p:nvSpPr>
         <p:spPr>
           <a:xfrm>
-            <a:off x="7205472" y="4233672"/>
+            <a:off x="7205472" y="4187952"/>
             <a:ext cx="4434840" cy="201168"/>
           </a:xfrm>
           <a:prstGeom prst="rect">
@@ -7762,8 +7764,8 @@
         </p:nvSpPr>
         <p:spPr>
           <a:xfrm>
-            <a:off x="7205472" y="4453128"/>
-            <a:ext cx="4434840" cy="365760"/>
+            <a:off x="7205472" y="4407408"/>
+            <a:ext cx="4434840" cy="274320"/>
           </a:xfrm>
           <a:prstGeom prst="rect">
             <a:avLst/>
@@ -8349,7 +8351,7 @@
                 </a:solidFill>
                 <a:latin typeface="Calibri"/>
               </a:rPr>
-              <a:t>11 / 15 · CONFIDENTIAL</a:t>
+              <a:t>11 / 17 · CONFIDENTIAL</a:t>
             </a:r>
           </a:p>
         </p:txBody>
@@ -10626,7 +10628,7 @@
                 </a:solidFill>
                 <a:latin typeface="Calibri"/>
               </a:rPr>
-              <a:t>12 / 15 · CONFIDENTIAL</a:t>
+              <a:t>12 / 17 · CONFIDENTIAL</a:t>
             </a:r>
           </a:p>
         </p:txBody>
@@ -12504,7 +12506,7 @@
                 </a:solidFill>
                 <a:latin typeface="Calibri"/>
               </a:rPr>
-              <a:t>13 / 15 · CONFIDENTIAL</a:t>
+              <a:t>13 / 17 · CONFIDENTIAL</a:t>
             </a:r>
           </a:p>
         </p:txBody>
@@ -13762,7 +13764,7 @@
                 </a:solidFill>
                 <a:latin typeface="Calibri"/>
               </a:rPr>
-              <a:t>14 / 15 · CONFIDENTIAL</a:t>
+              <a:t>14 / 17 · CONFIDENTIAL</a:t>
             </a:r>
           </a:p>
         </p:txBody>
@@ -14341,7 +14343,7 @@
                 </a:solidFill>
                 <a:latin typeface="Calibri"/>
               </a:rPr>
-              <a:t>Start with 2 pilots — recommend Visual Inspection + Predictive Maintenance. ROI proven in 12 weeks, then scale across plants.</a:t>
+              <a:t>Start with 2 pilots — Visual Inspection at HMGMA (IONIQ paint) + Predictive Maintenance at Ulsan stamping / Asan welding. ROI proven in 12 weeks, then scale across the global Hyundai plant network.</a:t>
             </a:r>
           </a:p>
         </p:txBody>
@@ -14458,7 +14460,745 @@
                 </a:solidFill>
                 <a:latin typeface="Calibri"/>
               </a:rPr>
-              <a:t>15 / 15</a:t>
+              <a:t>15 / 17</a:t>
+            </a:r>
+          </a:p>
+        </p:txBody>
+      </p:sp>
+    </p:spTree>
+  </p:cSld>
+  <p:clrMapOvr>
+    <a:masterClrMapping/>
+  </p:clrMapOvr>
+</p:sld>
+</file>
+
+<file path=ppt/slides/slide16.xml><?xml version="1.0" encoding="utf-8"?>
+<p:sld xmlns:a="http://schemas.openxmlformats.org/drawingml/2006/main" xmlns:p="http://schemas.openxmlformats.org/presentationml/2006/main" xmlns:r="http://schemas.openxmlformats.org/officeDocument/2006/relationships">
+  <p:cSld>
+    <p:spTree>
+      <p:nvGrpSpPr>
+        <p:cNvPr id="1" name=""/>
+        <p:cNvGrpSpPr/>
+        <p:nvPr/>
+      </p:nvGrpSpPr>
+      <p:grpSpPr/>
+      <p:sp>
+        <p:nvSpPr>
+          <p:cNvPr id="2" name="Rectangle 1"/>
+          <p:cNvSpPr/>
+          <p:nvPr/>
+        </p:nvSpPr>
+        <p:spPr>
+          <a:xfrm>
+            <a:off x="0" y="0"/>
+            <a:ext cx="12191695" cy="6858000"/>
+          </a:xfrm>
+          <a:prstGeom prst="rect">
+            <a:avLst/>
+          </a:prstGeom>
+          <a:solidFill>
+            <a:srgbClr val="F8FAFC"/>
+          </a:solidFill>
+          <a:ln>
+            <a:noFill/>
+          </a:ln>
+          <a:effectLst/>
+        </p:spPr>
+        <p:style>
+          <a:lnRef idx="1">
+            <a:schemeClr val="accent1"/>
+          </a:lnRef>
+          <a:fillRef idx="3">
+            <a:schemeClr val="accent1"/>
+          </a:fillRef>
+          <a:effectRef idx="2">
+            <a:schemeClr val="accent1"/>
+          </a:effectRef>
+          <a:fontRef idx="minor">
+            <a:schemeClr val="lt1"/>
+          </a:fontRef>
+        </p:style>
+        <p:txBody>
+          <a:bodyPr rtlCol="0" anchor="ctr"/>
+          <a:lstStyle/>
+          <a:p>
+            <a:pPr algn="ctr"/>
+          </a:p>
+        </p:txBody>
+      </p:sp>
+      <p:sp>
+        <p:nvSpPr>
+          <p:cNvPr id="3" name="Rectangle 2"/>
+          <p:cNvSpPr/>
+          <p:nvPr/>
+        </p:nvSpPr>
+        <p:spPr>
+          <a:xfrm>
+            <a:off x="0" y="0"/>
+            <a:ext cx="12191695" cy="640080"/>
+          </a:xfrm>
+          <a:prstGeom prst="rect">
+            <a:avLst/>
+          </a:prstGeom>
+          <a:solidFill>
+            <a:srgbClr val="1A2754"/>
+          </a:solidFill>
+          <a:ln>
+            <a:noFill/>
+          </a:ln>
+          <a:effectLst/>
+        </p:spPr>
+        <p:style>
+          <a:lnRef idx="1">
+            <a:schemeClr val="accent1"/>
+          </a:lnRef>
+          <a:fillRef idx="3">
+            <a:schemeClr val="accent1"/>
+          </a:fillRef>
+          <a:effectRef idx="2">
+            <a:schemeClr val="accent1"/>
+          </a:effectRef>
+          <a:fontRef idx="minor">
+            <a:schemeClr val="lt1"/>
+          </a:fontRef>
+        </p:style>
+        <p:txBody>
+          <a:bodyPr rtlCol="0" anchor="ctr"/>
+          <a:lstStyle/>
+          <a:p>
+            <a:pPr algn="ctr"/>
+          </a:p>
+        </p:txBody>
+      </p:sp>
+      <p:sp>
+        <p:nvSpPr>
+          <p:cNvPr id="4" name="TextBox 3"/>
+          <p:cNvSpPr txBox="1"/>
+          <p:nvPr/>
+        </p:nvSpPr>
+        <p:spPr>
+          <a:xfrm>
+            <a:off x="457200" y="0"/>
+            <a:ext cx="2286000" cy="640080"/>
+          </a:xfrm>
+          <a:prstGeom prst="rect">
+            <a:avLst/>
+          </a:prstGeom>
+          <a:noFill/>
+        </p:spPr>
+        <p:txBody>
+          <a:bodyPr wrap="square" lIns="0" rIns="0" tIns="0" bIns="0" anchor="ctr">
+            <a:spAutoFit/>
+          </a:bodyPr>
+          <a:lstStyle/>
+          <a:p>
+            <a:pPr algn="l">
+              <a:lnSpc>
+                <a:spcPct val="120000"/>
+              </a:lnSpc>
+            </a:pPr>
+            <a:r>
+              <a:rPr sz="1000" b="1" i="0">
+                <a:solidFill>
+                  <a:srgbClr val="CBD5E1"/>
+                </a:solidFill>
+                <a:latin typeface="Calibri"/>
+              </a:rPr>
+              <a:t>APPENDIX · PILOT 1</a:t>
+            </a:r>
+          </a:p>
+        </p:txBody>
+      </p:sp>
+      <p:sp>
+        <p:nvSpPr>
+          <p:cNvPr id="5" name="TextBox 4"/>
+          <p:cNvSpPr txBox="1"/>
+          <p:nvPr/>
+        </p:nvSpPr>
+        <p:spPr>
+          <a:xfrm>
+            <a:off x="2743200" y="0"/>
+            <a:ext cx="6400800" cy="640080"/>
+          </a:xfrm>
+          <a:prstGeom prst="rect">
+            <a:avLst/>
+          </a:prstGeom>
+          <a:noFill/>
+        </p:spPr>
+        <p:txBody>
+          <a:bodyPr wrap="square" lIns="0" rIns="0" tIns="0" bIns="0" anchor="ctr">
+            <a:spAutoFit/>
+          </a:bodyPr>
+          <a:lstStyle/>
+          <a:p>
+            <a:pPr algn="ctr">
+              <a:lnSpc>
+                <a:spcPct val="120000"/>
+              </a:lnSpc>
+            </a:pPr>
+            <a:r>
+              <a:rPr sz="1800" b="1" i="0">
+                <a:solidFill>
+                  <a:srgbClr val="FFFFFF"/>
+                </a:solidFill>
+                <a:latin typeface="Calibri"/>
+              </a:rPr>
+              <a:t>Visual Inspection — Reference Architecture</a:t>
+            </a:r>
+          </a:p>
+        </p:txBody>
+      </p:sp>
+      <p:sp>
+        <p:nvSpPr>
+          <p:cNvPr id="6" name="TextBox 5"/>
+          <p:cNvSpPr txBox="1"/>
+          <p:nvPr/>
+        </p:nvSpPr>
+        <p:spPr>
+          <a:xfrm>
+            <a:off x="9144000" y="0"/>
+            <a:ext cx="2560320" cy="640080"/>
+          </a:xfrm>
+          <a:prstGeom prst="rect">
+            <a:avLst/>
+          </a:prstGeom>
+          <a:noFill/>
+        </p:spPr>
+        <p:txBody>
+          <a:bodyPr wrap="square" lIns="0" rIns="0" tIns="0" bIns="0" anchor="ctr">
+            <a:spAutoFit/>
+          </a:bodyPr>
+          <a:lstStyle/>
+          <a:p>
+            <a:pPr algn="r">
+              <a:lnSpc>
+                <a:spcPct val="120000"/>
+              </a:lnSpc>
+            </a:pPr>
+            <a:r>
+              <a:rPr sz="1000" b="0" i="1">
+                <a:solidFill>
+                  <a:srgbClr val="CBD5E1"/>
+                </a:solidFill>
+                <a:latin typeface="Calibri"/>
+              </a:rPr>
+              <a:t>HMGMA · IONIQ paint shop</a:t>
+            </a:r>
+          </a:p>
+        </p:txBody>
+      </p:sp>
+      <p:pic>
+        <p:nvPicPr>
+          <p:cNvPr id="7" name="Picture 6" descr="architecture_visual_inspection.png"/>
+          <p:cNvPicPr>
+            <a:picLocks noChangeAspect="1"/>
+          </p:cNvPicPr>
+          <p:nvPr/>
+        </p:nvPicPr>
+        <p:blipFill>
+          <a:blip r:embed="rId2"/>
+          <a:stretch>
+            <a:fillRect/>
+          </a:stretch>
+        </p:blipFill>
+        <p:spPr>
+          <a:xfrm>
+            <a:off x="365760" y="777240"/>
+            <a:ext cx="11430000" cy="5577840"/>
+          </a:xfrm>
+          <a:prstGeom prst="rect">
+            <a:avLst/>
+          </a:prstGeom>
+        </p:spPr>
+      </p:pic>
+      <p:sp>
+        <p:nvSpPr>
+          <p:cNvPr id="8" name="Rectangle 7"/>
+          <p:cNvSpPr/>
+          <p:nvPr/>
+        </p:nvSpPr>
+        <p:spPr>
+          <a:xfrm>
+            <a:off x="0" y="6400800"/>
+            <a:ext cx="12191695" cy="457200"/>
+          </a:xfrm>
+          <a:prstGeom prst="rect">
+            <a:avLst/>
+          </a:prstGeom>
+          <a:solidFill>
+            <a:srgbClr val="0F1729"/>
+          </a:solidFill>
+          <a:ln>
+            <a:noFill/>
+          </a:ln>
+          <a:effectLst/>
+        </p:spPr>
+        <p:style>
+          <a:lnRef idx="1">
+            <a:schemeClr val="accent1"/>
+          </a:lnRef>
+          <a:fillRef idx="3">
+            <a:schemeClr val="accent1"/>
+          </a:fillRef>
+          <a:effectRef idx="2">
+            <a:schemeClr val="accent1"/>
+          </a:effectRef>
+          <a:fontRef idx="minor">
+            <a:schemeClr val="lt1"/>
+          </a:fontRef>
+        </p:style>
+        <p:txBody>
+          <a:bodyPr rtlCol="0" anchor="ctr"/>
+          <a:lstStyle/>
+          <a:p>
+            <a:pPr algn="ctr"/>
+          </a:p>
+        </p:txBody>
+      </p:sp>
+      <p:sp>
+        <p:nvSpPr>
+          <p:cNvPr id="9" name="TextBox 8"/>
+          <p:cNvSpPr txBox="1"/>
+          <p:nvPr/>
+        </p:nvSpPr>
+        <p:spPr>
+          <a:xfrm>
+            <a:off x="457200" y="6446520"/>
+            <a:ext cx="7315200" cy="365760"/>
+          </a:xfrm>
+          <a:prstGeom prst="rect">
+            <a:avLst/>
+          </a:prstGeom>
+          <a:noFill/>
+        </p:spPr>
+        <p:txBody>
+          <a:bodyPr wrap="square" lIns="0" rIns="0" tIns="0" bIns="0" anchor="ctr">
+            <a:spAutoFit/>
+          </a:bodyPr>
+          <a:lstStyle/>
+          <a:p>
+            <a:pPr algn="l">
+              <a:lnSpc>
+                <a:spcPct val="120000"/>
+              </a:lnSpc>
+            </a:pPr>
+            <a:r>
+              <a:rPr sz="900" b="1" i="0">
+                <a:solidFill>
+                  <a:srgbClr val="CBD5E1"/>
+                </a:solidFill>
+                <a:latin typeface="Calibri"/>
+              </a:rPr>
+              <a:t>PeopleTech · AI Manufacturing Practice</a:t>
+            </a:r>
+          </a:p>
+        </p:txBody>
+      </p:sp>
+      <p:sp>
+        <p:nvSpPr>
+          <p:cNvPr id="10" name="TextBox 9"/>
+          <p:cNvSpPr txBox="1"/>
+          <p:nvPr/>
+        </p:nvSpPr>
+        <p:spPr>
+          <a:xfrm>
+            <a:off x="7772400" y="6446520"/>
+            <a:ext cx="3931920" cy="365760"/>
+          </a:xfrm>
+          <a:prstGeom prst="rect">
+            <a:avLst/>
+          </a:prstGeom>
+          <a:noFill/>
+        </p:spPr>
+        <p:txBody>
+          <a:bodyPr wrap="square" lIns="0" rIns="0" tIns="0" bIns="0" anchor="ctr">
+            <a:spAutoFit/>
+          </a:bodyPr>
+          <a:lstStyle/>
+          <a:p>
+            <a:pPr algn="r">
+              <a:lnSpc>
+                <a:spcPct val="120000"/>
+              </a:lnSpc>
+            </a:pPr>
+            <a:r>
+              <a:rPr sz="900" b="0" i="0">
+                <a:solidFill>
+                  <a:srgbClr val="94A3B8"/>
+                </a:solidFill>
+                <a:latin typeface="Calibri"/>
+              </a:rPr>
+              <a:t>16 / 17 · CONFIDENTIAL</a:t>
+            </a:r>
+          </a:p>
+        </p:txBody>
+      </p:sp>
+    </p:spTree>
+  </p:cSld>
+  <p:clrMapOvr>
+    <a:masterClrMapping/>
+  </p:clrMapOvr>
+</p:sld>
+</file>
+
+<file path=ppt/slides/slide17.xml><?xml version="1.0" encoding="utf-8"?>
+<p:sld xmlns:a="http://schemas.openxmlformats.org/drawingml/2006/main" xmlns:p="http://schemas.openxmlformats.org/presentationml/2006/main" xmlns:r="http://schemas.openxmlformats.org/officeDocument/2006/relationships">
+  <p:cSld>
+    <p:spTree>
+      <p:nvGrpSpPr>
+        <p:cNvPr id="1" name=""/>
+        <p:cNvGrpSpPr/>
+        <p:nvPr/>
+      </p:nvGrpSpPr>
+      <p:grpSpPr/>
+      <p:sp>
+        <p:nvSpPr>
+          <p:cNvPr id="2" name="Rectangle 1"/>
+          <p:cNvSpPr/>
+          <p:nvPr/>
+        </p:nvSpPr>
+        <p:spPr>
+          <a:xfrm>
+            <a:off x="0" y="0"/>
+            <a:ext cx="12191695" cy="6858000"/>
+          </a:xfrm>
+          <a:prstGeom prst="rect">
+            <a:avLst/>
+          </a:prstGeom>
+          <a:solidFill>
+            <a:srgbClr val="F8FAFC"/>
+          </a:solidFill>
+          <a:ln>
+            <a:noFill/>
+          </a:ln>
+          <a:effectLst/>
+        </p:spPr>
+        <p:style>
+          <a:lnRef idx="1">
+            <a:schemeClr val="accent1"/>
+          </a:lnRef>
+          <a:fillRef idx="3">
+            <a:schemeClr val="accent1"/>
+          </a:fillRef>
+          <a:effectRef idx="2">
+            <a:schemeClr val="accent1"/>
+          </a:effectRef>
+          <a:fontRef idx="minor">
+            <a:schemeClr val="lt1"/>
+          </a:fontRef>
+        </p:style>
+        <p:txBody>
+          <a:bodyPr rtlCol="0" anchor="ctr"/>
+          <a:lstStyle/>
+          <a:p>
+            <a:pPr algn="ctr"/>
+          </a:p>
+        </p:txBody>
+      </p:sp>
+      <p:sp>
+        <p:nvSpPr>
+          <p:cNvPr id="3" name="Rectangle 2"/>
+          <p:cNvSpPr/>
+          <p:nvPr/>
+        </p:nvSpPr>
+        <p:spPr>
+          <a:xfrm>
+            <a:off x="0" y="0"/>
+            <a:ext cx="12191695" cy="640080"/>
+          </a:xfrm>
+          <a:prstGeom prst="rect">
+            <a:avLst/>
+          </a:prstGeom>
+          <a:solidFill>
+            <a:srgbClr val="1A2754"/>
+          </a:solidFill>
+          <a:ln>
+            <a:noFill/>
+          </a:ln>
+          <a:effectLst/>
+        </p:spPr>
+        <p:style>
+          <a:lnRef idx="1">
+            <a:schemeClr val="accent1"/>
+          </a:lnRef>
+          <a:fillRef idx="3">
+            <a:schemeClr val="accent1"/>
+          </a:fillRef>
+          <a:effectRef idx="2">
+            <a:schemeClr val="accent1"/>
+          </a:effectRef>
+          <a:fontRef idx="minor">
+            <a:schemeClr val="lt1"/>
+          </a:fontRef>
+        </p:style>
+        <p:txBody>
+          <a:bodyPr rtlCol="0" anchor="ctr"/>
+          <a:lstStyle/>
+          <a:p>
+            <a:pPr algn="ctr"/>
+          </a:p>
+        </p:txBody>
+      </p:sp>
+      <p:sp>
+        <p:nvSpPr>
+          <p:cNvPr id="4" name="TextBox 3"/>
+          <p:cNvSpPr txBox="1"/>
+          <p:nvPr/>
+        </p:nvSpPr>
+        <p:spPr>
+          <a:xfrm>
+            <a:off x="457200" y="0"/>
+            <a:ext cx="2286000" cy="640080"/>
+          </a:xfrm>
+          <a:prstGeom prst="rect">
+            <a:avLst/>
+          </a:prstGeom>
+          <a:noFill/>
+        </p:spPr>
+        <p:txBody>
+          <a:bodyPr wrap="square" lIns="0" rIns="0" tIns="0" bIns="0" anchor="ctr">
+            <a:spAutoFit/>
+          </a:bodyPr>
+          <a:lstStyle/>
+          <a:p>
+            <a:pPr algn="l">
+              <a:lnSpc>
+                <a:spcPct val="120000"/>
+              </a:lnSpc>
+            </a:pPr>
+            <a:r>
+              <a:rPr sz="1000" b="1" i="0">
+                <a:solidFill>
+                  <a:srgbClr val="CBD5E1"/>
+                </a:solidFill>
+                <a:latin typeface="Calibri"/>
+              </a:rPr>
+              <a:t>APPENDIX · PILOT 2</a:t>
+            </a:r>
+          </a:p>
+        </p:txBody>
+      </p:sp>
+      <p:sp>
+        <p:nvSpPr>
+          <p:cNvPr id="5" name="TextBox 4"/>
+          <p:cNvSpPr txBox="1"/>
+          <p:nvPr/>
+        </p:nvSpPr>
+        <p:spPr>
+          <a:xfrm>
+            <a:off x="2743200" y="0"/>
+            <a:ext cx="6400800" cy="640080"/>
+          </a:xfrm>
+          <a:prstGeom prst="rect">
+            <a:avLst/>
+          </a:prstGeom>
+          <a:noFill/>
+        </p:spPr>
+        <p:txBody>
+          <a:bodyPr wrap="square" lIns="0" rIns="0" tIns="0" bIns="0" anchor="ctr">
+            <a:spAutoFit/>
+          </a:bodyPr>
+          <a:lstStyle/>
+          <a:p>
+            <a:pPr algn="ctr">
+              <a:lnSpc>
+                <a:spcPct val="120000"/>
+              </a:lnSpc>
+            </a:pPr>
+            <a:r>
+              <a:rPr sz="1800" b="1" i="0">
+                <a:solidFill>
+                  <a:srgbClr val="FFFFFF"/>
+                </a:solidFill>
+                <a:latin typeface="Calibri"/>
+              </a:rPr>
+              <a:t>Predictive Maintenance — Reference Architecture</a:t>
+            </a:r>
+          </a:p>
+        </p:txBody>
+      </p:sp>
+      <p:sp>
+        <p:nvSpPr>
+          <p:cNvPr id="6" name="TextBox 5"/>
+          <p:cNvSpPr txBox="1"/>
+          <p:nvPr/>
+        </p:nvSpPr>
+        <p:spPr>
+          <a:xfrm>
+            <a:off x="9144000" y="0"/>
+            <a:ext cx="2560320" cy="640080"/>
+          </a:xfrm>
+          <a:prstGeom prst="rect">
+            <a:avLst/>
+          </a:prstGeom>
+          <a:noFill/>
+        </p:spPr>
+        <p:txBody>
+          <a:bodyPr wrap="square" lIns="0" rIns="0" tIns="0" bIns="0" anchor="ctr">
+            <a:spAutoFit/>
+          </a:bodyPr>
+          <a:lstStyle/>
+          <a:p>
+            <a:pPr algn="r">
+              <a:lnSpc>
+                <a:spcPct val="120000"/>
+              </a:lnSpc>
+            </a:pPr>
+            <a:r>
+              <a:rPr sz="1000" b="0" i="1">
+                <a:solidFill>
+                  <a:srgbClr val="CBD5E1"/>
+                </a:solidFill>
+                <a:latin typeface="Calibri"/>
+              </a:rPr>
+              <a:t>Ulsan stamping · Asan welding</a:t>
+            </a:r>
+          </a:p>
+        </p:txBody>
+      </p:sp>
+      <p:pic>
+        <p:nvPicPr>
+          <p:cNvPr id="7" name="Picture 6" descr="architecture_predictive_maintenance.png"/>
+          <p:cNvPicPr>
+            <a:picLocks noChangeAspect="1"/>
+          </p:cNvPicPr>
+          <p:nvPr/>
+        </p:nvPicPr>
+        <p:blipFill>
+          <a:blip r:embed="rId2"/>
+          <a:stretch>
+            <a:fillRect/>
+          </a:stretch>
+        </p:blipFill>
+        <p:spPr>
+          <a:xfrm>
+            <a:off x="365760" y="777240"/>
+            <a:ext cx="11430000" cy="5577840"/>
+          </a:xfrm>
+          <a:prstGeom prst="rect">
+            <a:avLst/>
+          </a:prstGeom>
+        </p:spPr>
+      </p:pic>
+      <p:sp>
+        <p:nvSpPr>
+          <p:cNvPr id="8" name="Rectangle 7"/>
+          <p:cNvSpPr/>
+          <p:nvPr/>
+        </p:nvSpPr>
+        <p:spPr>
+          <a:xfrm>
+            <a:off x="0" y="6400800"/>
+            <a:ext cx="12191695" cy="457200"/>
+          </a:xfrm>
+          <a:prstGeom prst="rect">
+            <a:avLst/>
+          </a:prstGeom>
+          <a:solidFill>
+            <a:srgbClr val="0F1729"/>
+          </a:solidFill>
+          <a:ln>
+            <a:noFill/>
+          </a:ln>
+          <a:effectLst/>
+        </p:spPr>
+        <p:style>
+          <a:lnRef idx="1">
+            <a:schemeClr val="accent1"/>
+          </a:lnRef>
+          <a:fillRef idx="3">
+            <a:schemeClr val="accent1"/>
+          </a:fillRef>
+          <a:effectRef idx="2">
+            <a:schemeClr val="accent1"/>
+          </a:effectRef>
+          <a:fontRef idx="minor">
+            <a:schemeClr val="lt1"/>
+          </a:fontRef>
+        </p:style>
+        <p:txBody>
+          <a:bodyPr rtlCol="0" anchor="ctr"/>
+          <a:lstStyle/>
+          <a:p>
+            <a:pPr algn="ctr"/>
+          </a:p>
+        </p:txBody>
+      </p:sp>
+      <p:sp>
+        <p:nvSpPr>
+          <p:cNvPr id="9" name="TextBox 8"/>
+          <p:cNvSpPr txBox="1"/>
+          <p:nvPr/>
+        </p:nvSpPr>
+        <p:spPr>
+          <a:xfrm>
+            <a:off x="457200" y="6446520"/>
+            <a:ext cx="7315200" cy="365760"/>
+          </a:xfrm>
+          <a:prstGeom prst="rect">
+            <a:avLst/>
+          </a:prstGeom>
+          <a:noFill/>
+        </p:spPr>
+        <p:txBody>
+          <a:bodyPr wrap="square" lIns="0" rIns="0" tIns="0" bIns="0" anchor="ctr">
+            <a:spAutoFit/>
+          </a:bodyPr>
+          <a:lstStyle/>
+          <a:p>
+            <a:pPr algn="l">
+              <a:lnSpc>
+                <a:spcPct val="120000"/>
+              </a:lnSpc>
+            </a:pPr>
+            <a:r>
+              <a:rPr sz="900" b="1" i="0">
+                <a:solidFill>
+                  <a:srgbClr val="CBD5E1"/>
+                </a:solidFill>
+                <a:latin typeface="Calibri"/>
+              </a:rPr>
+              <a:t>PeopleTech · AI Manufacturing Practice</a:t>
+            </a:r>
+          </a:p>
+        </p:txBody>
+      </p:sp>
+      <p:sp>
+        <p:nvSpPr>
+          <p:cNvPr id="10" name="TextBox 9"/>
+          <p:cNvSpPr txBox="1"/>
+          <p:nvPr/>
+        </p:nvSpPr>
+        <p:spPr>
+          <a:xfrm>
+            <a:off x="7772400" y="6446520"/>
+            <a:ext cx="3931920" cy="365760"/>
+          </a:xfrm>
+          <a:prstGeom prst="rect">
+            <a:avLst/>
+          </a:prstGeom>
+          <a:noFill/>
+        </p:spPr>
+        <p:txBody>
+          <a:bodyPr wrap="square" lIns="0" rIns="0" tIns="0" bIns="0" anchor="ctr">
+            <a:spAutoFit/>
+          </a:bodyPr>
+          <a:lstStyle/>
+          <a:p>
+            <a:pPr algn="r">
+              <a:lnSpc>
+                <a:spcPct val="120000"/>
+              </a:lnSpc>
+            </a:pPr>
+            <a:r>
+              <a:rPr sz="900" b="0" i="0">
+                <a:solidFill>
+                  <a:srgbClr val="94A3B8"/>
+                </a:solidFill>
+                <a:latin typeface="Calibri"/>
+              </a:rPr>
+              <a:t>17 / 17 · CONFIDENTIAL</a:t>
             </a:r>
           </a:p>
         </p:txBody>
@@ -14734,7 +15474,7 @@
         <p:spPr>
           <a:xfrm>
             <a:off x="457200" y="2011680"/>
-            <a:ext cx="6858000" cy="914400"/>
+            <a:ext cx="6858000" cy="822960"/>
           </a:xfrm>
           <a:prstGeom prst="rect">
             <a:avLst/>
@@ -14753,7 +15493,7 @@
               </a:lnSpc>
             </a:pPr>
             <a:r>
-              <a:rPr sz="1100" b="0" i="0">
+              <a:rPr sz="1050" b="0" i="0">
                 <a:solidFill>
                   <a:srgbClr val="475569"/>
                 </a:solidFill>
@@ -14772,7 +15512,134 @@
         </p:nvSpPr>
         <p:spPr>
           <a:xfrm>
-            <a:off x="457200" y="3383280"/>
+            <a:off x="457200" y="2880360"/>
+            <a:ext cx="6858000" cy="457200"/>
+          </a:xfrm>
+          <a:prstGeom prst="rect">
+            <a:avLst/>
+          </a:prstGeom>
+          <a:solidFill>
+            <a:srgbClr val="ECFDF5"/>
+          </a:solidFill>
+          <a:ln>
+            <a:noFill/>
+          </a:ln>
+          <a:effectLst/>
+        </p:spPr>
+        <p:style>
+          <a:lnRef idx="1">
+            <a:schemeClr val="accent1"/>
+          </a:lnRef>
+          <a:fillRef idx="3">
+            <a:schemeClr val="accent1"/>
+          </a:fillRef>
+          <a:effectRef idx="2">
+            <a:schemeClr val="accent1"/>
+          </a:effectRef>
+          <a:fontRef idx="minor">
+            <a:schemeClr val="lt1"/>
+          </a:fontRef>
+        </p:style>
+        <p:txBody>
+          <a:bodyPr rtlCol="0" anchor="ctr"/>
+          <a:lstStyle/>
+          <a:p>
+            <a:pPr algn="ctr"/>
+          </a:p>
+        </p:txBody>
+      </p:sp>
+      <p:sp>
+        <p:nvSpPr>
+          <p:cNvPr id="10" name="Rectangle 9"/>
+          <p:cNvSpPr/>
+          <p:nvPr/>
+        </p:nvSpPr>
+        <p:spPr>
+          <a:xfrm>
+            <a:off x="457200" y="2880360"/>
+            <a:ext cx="54864" cy="457200"/>
+          </a:xfrm>
+          <a:prstGeom prst="rect">
+            <a:avLst/>
+          </a:prstGeom>
+          <a:solidFill>
+            <a:srgbClr val="14A085"/>
+          </a:solidFill>
+          <a:ln>
+            <a:noFill/>
+          </a:ln>
+          <a:effectLst/>
+        </p:spPr>
+        <p:style>
+          <a:lnRef idx="1">
+            <a:schemeClr val="accent1"/>
+          </a:lnRef>
+          <a:fillRef idx="3">
+            <a:schemeClr val="accent1"/>
+          </a:fillRef>
+          <a:effectRef idx="2">
+            <a:schemeClr val="accent1"/>
+          </a:effectRef>
+          <a:fontRef idx="minor">
+            <a:schemeClr val="lt1"/>
+          </a:fontRef>
+        </p:style>
+        <p:txBody>
+          <a:bodyPr rtlCol="0" anchor="ctr"/>
+          <a:lstStyle/>
+          <a:p>
+            <a:pPr algn="ctr"/>
+          </a:p>
+        </p:txBody>
+      </p:sp>
+      <p:sp>
+        <p:nvSpPr>
+          <p:cNvPr id="11" name="TextBox 10"/>
+          <p:cNvSpPr txBox="1"/>
+          <p:nvPr/>
+        </p:nvSpPr>
+        <p:spPr>
+          <a:xfrm>
+            <a:off x="621792" y="2880360"/>
+            <a:ext cx="6583680" cy="457200"/>
+          </a:xfrm>
+          <a:prstGeom prst="rect">
+            <a:avLst/>
+          </a:prstGeom>
+          <a:noFill/>
+        </p:spPr>
+        <p:txBody>
+          <a:bodyPr wrap="square" lIns="0" rIns="0" tIns="0" bIns="0" anchor="ctr">
+            <a:spAutoFit/>
+          </a:bodyPr>
+          <a:lstStyle/>
+          <a:p>
+            <a:pPr algn="l">
+              <a:lnSpc>
+                <a:spcPct val="135000"/>
+              </a:lnSpc>
+            </a:pPr>
+            <a:r>
+              <a:rPr sz="950" b="0" i="1">
+                <a:solidFill>
+                  <a:srgbClr val="0D8A72"/>
+                </a:solidFill>
+                <a:latin typeface="Calibri"/>
+              </a:rPr>
+              <a:t>Hyundai already operates HMGICS Singapore as a smart-factory hub and has invested in AI via AIRS Company and Boston Dynamics. PeopleTech brings these innovations to production scale at Ulsan, Asan, HMGMA, HMMA, HMMC, HMI.</a:t>
+            </a:r>
+          </a:p>
+        </p:txBody>
+      </p:sp>
+      <p:sp>
+        <p:nvSpPr>
+          <p:cNvPr id="12" name="Rectangle 11"/>
+          <p:cNvSpPr/>
+          <p:nvPr/>
+        </p:nvSpPr>
+        <p:spPr>
+          <a:xfrm>
+            <a:off x="457200" y="3520440"/>
             <a:ext cx="6858000" cy="777240"/>
           </a:xfrm>
           <a:prstGeom prst="rect">
@@ -14810,13 +15677,13 @@
       </p:sp>
       <p:sp>
         <p:nvSpPr>
-          <p:cNvPr id="10" name="Rectangle 9"/>
+          <p:cNvPr id="13" name="Rectangle 12"/>
           <p:cNvSpPr/>
           <p:nvPr/>
         </p:nvSpPr>
         <p:spPr>
           <a:xfrm>
-            <a:off x="457200" y="3383280"/>
+            <a:off x="457200" y="3520440"/>
             <a:ext cx="54864" cy="777240"/>
           </a:xfrm>
           <a:prstGeom prst="rect">
@@ -14854,13 +15721,13 @@
       </p:sp>
       <p:sp>
         <p:nvSpPr>
-          <p:cNvPr id="11" name="TextBox 10"/>
-          <p:cNvSpPr txBox="1"/>
-          <p:nvPr/>
-        </p:nvSpPr>
-        <p:spPr>
-          <a:xfrm>
-            <a:off x="621792" y="3456432"/>
+          <p:cNvPr id="14" name="TextBox 13"/>
+          <p:cNvSpPr txBox="1"/>
+          <p:nvPr/>
+        </p:nvSpPr>
+        <p:spPr>
+          <a:xfrm>
+            <a:off x="621792" y="3593592"/>
             <a:ext cx="6583680" cy="274320"/>
           </a:xfrm>
           <a:prstGeom prst="rect">
@@ -14893,13 +15760,13 @@
       </p:sp>
       <p:sp>
         <p:nvSpPr>
-          <p:cNvPr id="12" name="TextBox 11"/>
-          <p:cNvSpPr txBox="1"/>
-          <p:nvPr/>
-        </p:nvSpPr>
-        <p:spPr>
-          <a:xfrm>
-            <a:off x="621792" y="3703320"/>
+          <p:cNvPr id="15" name="TextBox 14"/>
+          <p:cNvSpPr txBox="1"/>
+          <p:nvPr/>
+        </p:nvSpPr>
+        <p:spPr>
+          <a:xfrm>
+            <a:off x="621792" y="3840480"/>
             <a:ext cx="6583680" cy="457200"/>
           </a:xfrm>
           <a:prstGeom prst="rect">
@@ -14932,13 +15799,13 @@
       </p:sp>
       <p:sp>
         <p:nvSpPr>
-          <p:cNvPr id="13" name="Rectangle 12"/>
+          <p:cNvPr id="16" name="Rectangle 15"/>
           <p:cNvSpPr/>
           <p:nvPr/>
         </p:nvSpPr>
         <p:spPr>
           <a:xfrm>
-            <a:off x="457200" y="4251960"/>
+            <a:off x="457200" y="4389120"/>
             <a:ext cx="6858000" cy="777240"/>
           </a:xfrm>
           <a:prstGeom prst="rect">
@@ -14976,13 +15843,13 @@
       </p:sp>
       <p:sp>
         <p:nvSpPr>
-          <p:cNvPr id="14" name="Rectangle 13"/>
+          <p:cNvPr id="17" name="Rectangle 16"/>
           <p:cNvSpPr/>
           <p:nvPr/>
         </p:nvSpPr>
         <p:spPr>
           <a:xfrm>
-            <a:off x="457200" y="4251960"/>
+            <a:off x="457200" y="4389120"/>
             <a:ext cx="54864" cy="777240"/>
           </a:xfrm>
           <a:prstGeom prst="rect">
@@ -15020,13 +15887,13 @@
       </p:sp>
       <p:sp>
         <p:nvSpPr>
-          <p:cNvPr id="15" name="TextBox 14"/>
-          <p:cNvSpPr txBox="1"/>
-          <p:nvPr/>
-        </p:nvSpPr>
-        <p:spPr>
-          <a:xfrm>
-            <a:off x="621792" y="4325112"/>
+          <p:cNvPr id="18" name="TextBox 17"/>
+          <p:cNvSpPr txBox="1"/>
+          <p:nvPr/>
+        </p:nvSpPr>
+        <p:spPr>
+          <a:xfrm>
+            <a:off x="621792" y="4462272"/>
             <a:ext cx="6583680" cy="274320"/>
           </a:xfrm>
           <a:prstGeom prst="rect">
@@ -15059,13 +15926,13 @@
       </p:sp>
       <p:sp>
         <p:nvSpPr>
-          <p:cNvPr id="16" name="TextBox 15"/>
-          <p:cNvSpPr txBox="1"/>
-          <p:nvPr/>
-        </p:nvSpPr>
-        <p:spPr>
-          <a:xfrm>
-            <a:off x="621792" y="4572000"/>
+          <p:cNvPr id="19" name="TextBox 18"/>
+          <p:cNvSpPr txBox="1"/>
+          <p:nvPr/>
+        </p:nvSpPr>
+        <p:spPr>
+          <a:xfrm>
+            <a:off x="621792" y="4709160"/>
             <a:ext cx="6583680" cy="457200"/>
           </a:xfrm>
           <a:prstGeom prst="rect">
@@ -15098,13 +15965,13 @@
       </p:sp>
       <p:sp>
         <p:nvSpPr>
-          <p:cNvPr id="17" name="Rectangle 16"/>
+          <p:cNvPr id="20" name="Rectangle 19"/>
           <p:cNvSpPr/>
           <p:nvPr/>
         </p:nvSpPr>
         <p:spPr>
           <a:xfrm>
-            <a:off x="457200" y="5120640"/>
+            <a:off x="457200" y="5257800"/>
             <a:ext cx="6858000" cy="777240"/>
           </a:xfrm>
           <a:prstGeom prst="rect">
@@ -15142,13 +16009,13 @@
       </p:sp>
       <p:sp>
         <p:nvSpPr>
-          <p:cNvPr id="18" name="Rectangle 17"/>
+          <p:cNvPr id="21" name="Rectangle 20"/>
           <p:cNvSpPr/>
           <p:nvPr/>
         </p:nvSpPr>
         <p:spPr>
           <a:xfrm>
-            <a:off x="457200" y="5120640"/>
+            <a:off x="457200" y="5257800"/>
             <a:ext cx="54864" cy="777240"/>
           </a:xfrm>
           <a:prstGeom prst="rect">
@@ -15186,13 +16053,13 @@
       </p:sp>
       <p:sp>
         <p:nvSpPr>
-          <p:cNvPr id="19" name="TextBox 18"/>
-          <p:cNvSpPr txBox="1"/>
-          <p:nvPr/>
-        </p:nvSpPr>
-        <p:spPr>
-          <a:xfrm>
-            <a:off x="621792" y="5193792"/>
+          <p:cNvPr id="22" name="TextBox 21"/>
+          <p:cNvSpPr txBox="1"/>
+          <p:nvPr/>
+        </p:nvSpPr>
+        <p:spPr>
+          <a:xfrm>
+            <a:off x="621792" y="5330952"/>
             <a:ext cx="6583680" cy="274320"/>
           </a:xfrm>
           <a:prstGeom prst="rect">
@@ -15225,13 +16092,13 @@
       </p:sp>
       <p:sp>
         <p:nvSpPr>
-          <p:cNvPr id="20" name="TextBox 19"/>
-          <p:cNvSpPr txBox="1"/>
-          <p:nvPr/>
-        </p:nvSpPr>
-        <p:spPr>
-          <a:xfrm>
-            <a:off x="621792" y="5440680"/>
+          <p:cNvPr id="23" name="TextBox 22"/>
+          <p:cNvSpPr txBox="1"/>
+          <p:nvPr/>
+        </p:nvSpPr>
+        <p:spPr>
+          <a:xfrm>
+            <a:off x="621792" y="5577840"/>
             <a:ext cx="6583680" cy="457200"/>
           </a:xfrm>
           <a:prstGeom prst="rect">
@@ -15264,7 +16131,7 @@
       </p:sp>
       <p:sp>
         <p:nvSpPr>
-          <p:cNvPr id="21" name="Rectangle 20"/>
+          <p:cNvPr id="24" name="Rectangle 23"/>
           <p:cNvSpPr/>
           <p:nvPr/>
         </p:nvSpPr>
@@ -15308,7 +16175,7 @@
       </p:sp>
       <p:sp>
         <p:nvSpPr>
-          <p:cNvPr id="22" name="TextBox 21"/>
+          <p:cNvPr id="25" name="TextBox 24"/>
           <p:cNvSpPr txBox="1"/>
           <p:nvPr/>
         </p:nvSpPr>
@@ -15347,7 +16214,7 @@
       </p:sp>
       <p:sp>
         <p:nvSpPr>
-          <p:cNvPr id="23" name="TextBox 22"/>
+          <p:cNvPr id="26" name="TextBox 25"/>
           <p:cNvSpPr txBox="1"/>
           <p:nvPr/>
         </p:nvSpPr>
@@ -15386,7 +16253,7 @@
       </p:sp>
       <p:sp>
         <p:nvSpPr>
-          <p:cNvPr id="24" name="TextBox 23"/>
+          <p:cNvPr id="27" name="TextBox 26"/>
           <p:cNvSpPr txBox="1"/>
           <p:nvPr/>
         </p:nvSpPr>
@@ -15425,7 +16292,7 @@
       </p:sp>
       <p:sp>
         <p:nvSpPr>
-          <p:cNvPr id="25" name="TextBox 24"/>
+          <p:cNvPr id="28" name="TextBox 27"/>
           <p:cNvSpPr txBox="1"/>
           <p:nvPr/>
         </p:nvSpPr>
@@ -15464,7 +16331,7 @@
       </p:sp>
       <p:sp>
         <p:nvSpPr>
-          <p:cNvPr id="26" name="TextBox 25"/>
+          <p:cNvPr id="29" name="TextBox 28"/>
           <p:cNvSpPr txBox="1"/>
           <p:nvPr/>
         </p:nvSpPr>
@@ -15503,7 +16370,7 @@
       </p:sp>
       <p:sp>
         <p:nvSpPr>
-          <p:cNvPr id="27" name="TextBox 26"/>
+          <p:cNvPr id="30" name="TextBox 29"/>
           <p:cNvSpPr txBox="1"/>
           <p:nvPr/>
         </p:nvSpPr>
@@ -15542,7 +16409,7 @@
       </p:sp>
       <p:sp>
         <p:nvSpPr>
-          <p:cNvPr id="28" name="TextBox 27"/>
+          <p:cNvPr id="31" name="TextBox 30"/>
           <p:cNvSpPr txBox="1"/>
           <p:nvPr/>
         </p:nvSpPr>
@@ -15581,7 +16448,7 @@
       </p:sp>
       <p:sp>
         <p:nvSpPr>
-          <p:cNvPr id="29" name="TextBox 28"/>
+          <p:cNvPr id="32" name="TextBox 31"/>
           <p:cNvSpPr txBox="1"/>
           <p:nvPr/>
         </p:nvSpPr>
@@ -15620,7 +16487,7 @@
       </p:sp>
       <p:sp>
         <p:nvSpPr>
-          <p:cNvPr id="30" name="TextBox 29"/>
+          <p:cNvPr id="33" name="TextBox 32"/>
           <p:cNvSpPr txBox="1"/>
           <p:nvPr/>
         </p:nvSpPr>
@@ -15659,7 +16526,7 @@
       </p:sp>
       <p:sp>
         <p:nvSpPr>
-          <p:cNvPr id="31" name="Rectangle 30"/>
+          <p:cNvPr id="34" name="Rectangle 33"/>
           <p:cNvSpPr/>
           <p:nvPr/>
         </p:nvSpPr>
@@ -15703,7 +16570,7 @@
       </p:sp>
       <p:sp>
         <p:nvSpPr>
-          <p:cNvPr id="32" name="TextBox 31"/>
+          <p:cNvPr id="35" name="TextBox 34"/>
           <p:cNvSpPr txBox="1"/>
           <p:nvPr/>
         </p:nvSpPr>
@@ -15742,7 +16609,7 @@
       </p:sp>
       <p:sp>
         <p:nvSpPr>
-          <p:cNvPr id="33" name="TextBox 32"/>
+          <p:cNvPr id="36" name="TextBox 35"/>
           <p:cNvSpPr txBox="1"/>
           <p:nvPr/>
         </p:nvSpPr>
@@ -15774,7 +16641,7 @@
                 </a:solidFill>
                 <a:latin typeface="Calibri"/>
               </a:rPr>
-              <a:t>02 / 15 · CONFIDENTIAL</a:t>
+              <a:t>02 / 17 · CONFIDENTIAL</a:t>
             </a:r>
           </a:p>
         </p:txBody>
@@ -16050,7 +16917,7 @@
         <p:spPr>
           <a:xfrm>
             <a:off x="457200" y="1691640"/>
-            <a:ext cx="10972800" cy="640080"/>
+            <a:ext cx="10972800" cy="777240"/>
           </a:xfrm>
           <a:prstGeom prst="rect">
             <a:avLst/>
@@ -16075,7 +16942,7 @@
                 </a:solidFill>
                 <a:latin typeface="Calibri"/>
               </a:rPr>
-              <a:t>We never start with a multi-quarter program. We start by proving one use case end-to-end on a real line, then we scale what works. Each phase has fixed scope, fixed KPIs, and a go/no-go gate before the next.</a:t>
+              <a:t>We never start with a multi-quarter program. We start by proving one use case end-to-end on a real line, then we scale what works. Each phase has fixed scope, fixed KPIs, and a go/no-go gate before the next. Designed for the scale of Ulsan (~1.6M vehicles/year, world's largest auto plant) and the production cadence of Metaplant America (IONIQ 5 / IONIQ 9 line).</a:t>
             </a:r>
           </a:p>
         </p:txBody>
@@ -17365,7 +18232,7 @@
                 </a:solidFill>
                 <a:latin typeface="Calibri"/>
               </a:rPr>
-              <a:t>03 / 15 · CONFIDENTIAL</a:t>
+              <a:t>03 / 17 · CONFIDENTIAL</a:t>
             </a:r>
           </a:p>
         </p:txBody>
@@ -18675,7 +19542,7 @@
         <p:spPr>
           <a:xfrm>
             <a:off x="7040880" y="3246120"/>
-            <a:ext cx="4663440" cy="822960"/>
+            <a:ext cx="4663440" cy="777240"/>
           </a:xfrm>
           <a:prstGeom prst="rect">
             <a:avLst/>
@@ -18719,7 +19586,7 @@
         <p:spPr>
           <a:xfrm>
             <a:off x="7040880" y="3246120"/>
-            <a:ext cx="54864" cy="822960"/>
+            <a:ext cx="54864" cy="777240"/>
           </a:xfrm>
           <a:prstGeom prst="rect">
             <a:avLst/>
@@ -18802,7 +19669,7 @@
         <p:spPr>
           <a:xfrm>
             <a:off x="7205472" y="3538728"/>
-            <a:ext cx="4434840" cy="502920"/>
+            <a:ext cx="4434840" cy="457200"/>
           </a:xfrm>
           <a:prstGeom prst="rect">
             <a:avLst/>
@@ -18840,8 +19707,8 @@
         </p:nvSpPr>
         <p:spPr>
           <a:xfrm>
-            <a:off x="7040880" y="4160520"/>
-            <a:ext cx="4663440" cy="685800"/>
+            <a:off x="7040880" y="4114800"/>
+            <a:ext cx="4663440" cy="594360"/>
           </a:xfrm>
           <a:prstGeom prst="rect">
             <a:avLst/>
@@ -18884,8 +19751,8 @@
         </p:nvSpPr>
         <p:spPr>
           <a:xfrm>
-            <a:off x="7040880" y="4160520"/>
-            <a:ext cx="54864" cy="685800"/>
+            <a:off x="7040880" y="4114800"/>
+            <a:ext cx="54864" cy="594360"/>
           </a:xfrm>
           <a:prstGeom prst="rect">
             <a:avLst/>
@@ -18928,7 +19795,7 @@
         </p:nvSpPr>
         <p:spPr>
           <a:xfrm>
-            <a:off x="7205472" y="4233672"/>
+            <a:off x="7205472" y="4187952"/>
             <a:ext cx="4434840" cy="201168"/>
           </a:xfrm>
           <a:prstGeom prst="rect">
@@ -18967,8 +19834,8 @@
         </p:nvSpPr>
         <p:spPr>
           <a:xfrm>
-            <a:off x="7205472" y="4453128"/>
-            <a:ext cx="4434840" cy="365760"/>
+            <a:off x="7205472" y="4407408"/>
+            <a:ext cx="4434840" cy="274320"/>
           </a:xfrm>
           <a:prstGeom prst="rect">
             <a:avLst/>
@@ -19001,6 +19868,172 @@
       <p:sp>
         <p:nvSpPr>
           <p:cNvPr id="40" name="Rectangle 39"/>
+          <p:cNvSpPr/>
+          <p:nvPr/>
+        </p:nvSpPr>
+        <p:spPr>
+          <a:xfrm>
+            <a:off x="7040880" y="4800600"/>
+            <a:ext cx="4663440" cy="411480"/>
+          </a:xfrm>
+          <a:prstGeom prst="rect">
+            <a:avLst/>
+          </a:prstGeom>
+          <a:solidFill>
+            <a:srgbClr val="ECFDF5"/>
+          </a:solidFill>
+          <a:ln>
+            <a:noFill/>
+          </a:ln>
+          <a:effectLst/>
+        </p:spPr>
+        <p:style>
+          <a:lnRef idx="1">
+            <a:schemeClr val="accent1"/>
+          </a:lnRef>
+          <a:fillRef idx="3">
+            <a:schemeClr val="accent1"/>
+          </a:fillRef>
+          <a:effectRef idx="2">
+            <a:schemeClr val="accent1"/>
+          </a:effectRef>
+          <a:fontRef idx="minor">
+            <a:schemeClr val="lt1"/>
+          </a:fontRef>
+        </p:style>
+        <p:txBody>
+          <a:bodyPr rtlCol="0" anchor="ctr"/>
+          <a:lstStyle/>
+          <a:p>
+            <a:pPr algn="ctr"/>
+          </a:p>
+        </p:txBody>
+      </p:sp>
+      <p:sp>
+        <p:nvSpPr>
+          <p:cNvPr id="41" name="Rectangle 40"/>
+          <p:cNvSpPr/>
+          <p:nvPr/>
+        </p:nvSpPr>
+        <p:spPr>
+          <a:xfrm>
+            <a:off x="7040880" y="4800600"/>
+            <a:ext cx="54864" cy="411480"/>
+          </a:xfrm>
+          <a:prstGeom prst="rect">
+            <a:avLst/>
+          </a:prstGeom>
+          <a:solidFill>
+            <a:srgbClr val="14A085"/>
+          </a:solidFill>
+          <a:ln>
+            <a:noFill/>
+          </a:ln>
+          <a:effectLst/>
+        </p:spPr>
+        <p:style>
+          <a:lnRef idx="1">
+            <a:schemeClr val="accent1"/>
+          </a:lnRef>
+          <a:fillRef idx="3">
+            <a:schemeClr val="accent1"/>
+          </a:fillRef>
+          <a:effectRef idx="2">
+            <a:schemeClr val="accent1"/>
+          </a:effectRef>
+          <a:fontRef idx="minor">
+            <a:schemeClr val="lt1"/>
+          </a:fontRef>
+        </p:style>
+        <p:txBody>
+          <a:bodyPr rtlCol="0" anchor="ctr"/>
+          <a:lstStyle/>
+          <a:p>
+            <a:pPr algn="ctr"/>
+          </a:p>
+        </p:txBody>
+      </p:sp>
+      <p:sp>
+        <p:nvSpPr>
+          <p:cNvPr id="42" name="TextBox 41"/>
+          <p:cNvSpPr txBox="1"/>
+          <p:nvPr/>
+        </p:nvSpPr>
+        <p:spPr>
+          <a:xfrm>
+            <a:off x="7178040" y="4818888"/>
+            <a:ext cx="4480560" cy="164592"/>
+          </a:xfrm>
+          <a:prstGeom prst="rect">
+            <a:avLst/>
+          </a:prstGeom>
+          <a:noFill/>
+        </p:spPr>
+        <p:txBody>
+          <a:bodyPr wrap="square" lIns="0" rIns="0" tIns="0" bIns="0" anchor="t">
+            <a:spAutoFit/>
+          </a:bodyPr>
+          <a:lstStyle/>
+          <a:p>
+            <a:pPr algn="l">
+              <a:lnSpc>
+                <a:spcPct val="120000"/>
+              </a:lnSpc>
+            </a:pPr>
+            <a:r>
+              <a:rPr sz="800" b="1" i="0">
+                <a:solidFill>
+                  <a:srgbClr val="0D8A72"/>
+                </a:solidFill>
+                <a:latin typeface="Calibri"/>
+              </a:rPr>
+              <a:t>RECOMMENDED HYUNDAI START</a:t>
+            </a:r>
+          </a:p>
+        </p:txBody>
+      </p:sp>
+      <p:sp>
+        <p:nvSpPr>
+          <p:cNvPr id="43" name="TextBox 42"/>
+          <p:cNvSpPr txBox="1"/>
+          <p:nvPr/>
+        </p:nvSpPr>
+        <p:spPr>
+          <a:xfrm>
+            <a:off x="7178040" y="4965192"/>
+            <a:ext cx="4480560" cy="246888"/>
+          </a:xfrm>
+          <a:prstGeom prst="rect">
+            <a:avLst/>
+          </a:prstGeom>
+          <a:noFill/>
+        </p:spPr>
+        <p:txBody>
+          <a:bodyPr wrap="square" lIns="0" rIns="0" tIns="0" bIns="0" anchor="t">
+            <a:spAutoFit/>
+          </a:bodyPr>
+          <a:lstStyle/>
+          <a:p>
+            <a:pPr algn="l">
+              <a:lnSpc>
+                <a:spcPct val="130000"/>
+              </a:lnSpc>
+            </a:pPr>
+            <a:r>
+              <a:rPr sz="850" b="0" i="0">
+                <a:solidFill>
+                  <a:srgbClr val="1E293B"/>
+                </a:solidFill>
+                <a:latin typeface="Calibri"/>
+              </a:rPr>
+              <a:t>Paint shop · IONIQ 5 / IONIQ 9 line at Metaplant America (HMGMA) — newest line, highest variant complexity, premium-segment defect sensitivity. Fast-follow on Tucson / Santa Fe paint at HMMA.</a:t>
+            </a:r>
+          </a:p>
+        </p:txBody>
+      </p:sp>
+      <p:sp>
+        <p:nvSpPr>
+          <p:cNvPr id="44" name="Rectangle 43"/>
           <p:cNvSpPr/>
           <p:nvPr/>
         </p:nvSpPr>
@@ -19044,7 +20077,7 @@
       </p:sp>
       <p:sp>
         <p:nvSpPr>
-          <p:cNvPr id="41" name="Rectangle 40"/>
+          <p:cNvPr id="45" name="Rectangle 44"/>
           <p:cNvSpPr/>
           <p:nvPr/>
         </p:nvSpPr>
@@ -19088,7 +20121,7 @@
       </p:sp>
       <p:sp>
         <p:nvSpPr>
-          <p:cNvPr id="42" name="TextBox 41"/>
+          <p:cNvPr id="46" name="TextBox 45"/>
           <p:cNvSpPr txBox="1"/>
           <p:nvPr/>
         </p:nvSpPr>
@@ -19127,7 +20160,7 @@
       </p:sp>
       <p:sp>
         <p:nvSpPr>
-          <p:cNvPr id="43" name="TextBox 42"/>
+          <p:cNvPr id="47" name="TextBox 46"/>
           <p:cNvSpPr txBox="1"/>
           <p:nvPr/>
         </p:nvSpPr>
@@ -19166,7 +20199,7 @@
       </p:sp>
       <p:sp>
         <p:nvSpPr>
-          <p:cNvPr id="44" name="TextBox 43"/>
+          <p:cNvPr id="48" name="TextBox 47"/>
           <p:cNvSpPr txBox="1"/>
           <p:nvPr/>
         </p:nvSpPr>
@@ -19205,7 +20238,7 @@
       </p:sp>
       <p:sp>
         <p:nvSpPr>
-          <p:cNvPr id="45" name="TextBox 44"/>
+          <p:cNvPr id="49" name="TextBox 48"/>
           <p:cNvSpPr txBox="1"/>
           <p:nvPr/>
         </p:nvSpPr>
@@ -19244,7 +20277,7 @@
       </p:sp>
       <p:sp>
         <p:nvSpPr>
-          <p:cNvPr id="46" name="TextBox 45"/>
+          <p:cNvPr id="50" name="TextBox 49"/>
           <p:cNvSpPr txBox="1"/>
           <p:nvPr/>
         </p:nvSpPr>
@@ -19283,7 +20316,7 @@
       </p:sp>
       <p:sp>
         <p:nvSpPr>
-          <p:cNvPr id="47" name="TextBox 46"/>
+          <p:cNvPr id="51" name="TextBox 50"/>
           <p:cNvSpPr txBox="1"/>
           <p:nvPr/>
         </p:nvSpPr>
@@ -19322,7 +20355,7 @@
       </p:sp>
       <p:sp>
         <p:nvSpPr>
-          <p:cNvPr id="48" name="TextBox 47"/>
+          <p:cNvPr id="52" name="TextBox 51"/>
           <p:cNvSpPr txBox="1"/>
           <p:nvPr/>
         </p:nvSpPr>
@@ -19361,7 +20394,7 @@
       </p:sp>
       <p:sp>
         <p:nvSpPr>
-          <p:cNvPr id="49" name="TextBox 48"/>
+          <p:cNvPr id="53" name="TextBox 52"/>
           <p:cNvSpPr txBox="1"/>
           <p:nvPr/>
         </p:nvSpPr>
@@ -19400,7 +20433,7 @@
       </p:sp>
       <p:sp>
         <p:nvSpPr>
-          <p:cNvPr id="50" name="TextBox 49"/>
+          <p:cNvPr id="54" name="TextBox 53"/>
           <p:cNvSpPr txBox="1"/>
           <p:nvPr/>
         </p:nvSpPr>
@@ -19439,7 +20472,7 @@
       </p:sp>
       <p:sp>
         <p:nvSpPr>
-          <p:cNvPr id="51" name="Rectangle 50"/>
+          <p:cNvPr id="55" name="Rectangle 54"/>
           <p:cNvSpPr/>
           <p:nvPr/>
         </p:nvSpPr>
@@ -19483,7 +20516,7 @@
       </p:sp>
       <p:sp>
         <p:nvSpPr>
-          <p:cNvPr id="52" name="TextBox 51"/>
+          <p:cNvPr id="56" name="TextBox 55"/>
           <p:cNvSpPr txBox="1"/>
           <p:nvPr/>
         </p:nvSpPr>
@@ -19522,7 +20555,7 @@
       </p:sp>
       <p:sp>
         <p:nvSpPr>
-          <p:cNvPr id="53" name="TextBox 52"/>
+          <p:cNvPr id="57" name="TextBox 56"/>
           <p:cNvSpPr txBox="1"/>
           <p:nvPr/>
         </p:nvSpPr>
@@ -19554,7 +20587,7 @@
                 </a:solidFill>
                 <a:latin typeface="Calibri"/>
               </a:rPr>
-              <a:t>04 / 15 · CONFIDENTIAL</a:t>
+              <a:t>04 / 17 · CONFIDENTIAL</a:t>
             </a:r>
           </a:p>
         </p:txBody>
@@ -20864,7 +21897,7 @@
         <p:spPr>
           <a:xfrm>
             <a:off x="7040880" y="3246120"/>
-            <a:ext cx="4663440" cy="822960"/>
+            <a:ext cx="4663440" cy="777240"/>
           </a:xfrm>
           <a:prstGeom prst="rect">
             <a:avLst/>
@@ -20908,7 +21941,7 @@
         <p:spPr>
           <a:xfrm>
             <a:off x="7040880" y="3246120"/>
-            <a:ext cx="54864" cy="822960"/>
+            <a:ext cx="54864" cy="777240"/>
           </a:xfrm>
           <a:prstGeom prst="rect">
             <a:avLst/>
@@ -20991,7 +22024,7 @@
         <p:spPr>
           <a:xfrm>
             <a:off x="7205472" y="3538728"/>
-            <a:ext cx="4434840" cy="502920"/>
+            <a:ext cx="4434840" cy="457200"/>
           </a:xfrm>
           <a:prstGeom prst="rect">
             <a:avLst/>
@@ -21029,8 +22062,8 @@
         </p:nvSpPr>
         <p:spPr>
           <a:xfrm>
-            <a:off x="7040880" y="4160520"/>
-            <a:ext cx="4663440" cy="685800"/>
+            <a:off x="7040880" y="4114800"/>
+            <a:ext cx="4663440" cy="594360"/>
           </a:xfrm>
           <a:prstGeom prst="rect">
             <a:avLst/>
@@ -21073,8 +22106,8 @@
         </p:nvSpPr>
         <p:spPr>
           <a:xfrm>
-            <a:off x="7040880" y="4160520"/>
-            <a:ext cx="54864" cy="685800"/>
+            <a:off x="7040880" y="4114800"/>
+            <a:ext cx="54864" cy="594360"/>
           </a:xfrm>
           <a:prstGeom prst="rect">
             <a:avLst/>
@@ -21117,7 +22150,7 @@
         </p:nvSpPr>
         <p:spPr>
           <a:xfrm>
-            <a:off x="7205472" y="4233672"/>
+            <a:off x="7205472" y="4187952"/>
             <a:ext cx="4434840" cy="201168"/>
           </a:xfrm>
           <a:prstGeom prst="rect">
@@ -21156,8 +22189,8 @@
         </p:nvSpPr>
         <p:spPr>
           <a:xfrm>
-            <a:off x="7205472" y="4453128"/>
-            <a:ext cx="4434840" cy="365760"/>
+            <a:off x="7205472" y="4407408"/>
+            <a:ext cx="4434840" cy="274320"/>
           </a:xfrm>
           <a:prstGeom prst="rect">
             <a:avLst/>
@@ -21743,7 +22776,7 @@
                 </a:solidFill>
                 <a:latin typeface="Calibri"/>
               </a:rPr>
-              <a:t>05 / 15 · CONFIDENTIAL</a:t>
+              <a:t>05 / 17 · CONFIDENTIAL</a:t>
             </a:r>
           </a:p>
         </p:txBody>
@@ -23053,7 +24086,7 @@
         <p:spPr>
           <a:xfrm>
             <a:off x="7040880" y="3246120"/>
-            <a:ext cx="4663440" cy="822960"/>
+            <a:ext cx="4663440" cy="777240"/>
           </a:xfrm>
           <a:prstGeom prst="rect">
             <a:avLst/>
@@ -23097,7 +24130,7 @@
         <p:spPr>
           <a:xfrm>
             <a:off x="7040880" y="3246120"/>
-            <a:ext cx="54864" cy="822960"/>
+            <a:ext cx="54864" cy="777240"/>
           </a:xfrm>
           <a:prstGeom prst="rect">
             <a:avLst/>
@@ -23180,7 +24213,7 @@
         <p:spPr>
           <a:xfrm>
             <a:off x="7205472" y="3538728"/>
-            <a:ext cx="4434840" cy="502920"/>
+            <a:ext cx="4434840" cy="457200"/>
           </a:xfrm>
           <a:prstGeom prst="rect">
             <a:avLst/>
@@ -23218,8 +24251,8 @@
         </p:nvSpPr>
         <p:spPr>
           <a:xfrm>
-            <a:off x="7040880" y="4160520"/>
-            <a:ext cx="4663440" cy="685800"/>
+            <a:off x="7040880" y="4114800"/>
+            <a:ext cx="4663440" cy="594360"/>
           </a:xfrm>
           <a:prstGeom prst="rect">
             <a:avLst/>
@@ -23262,8 +24295,8 @@
         </p:nvSpPr>
         <p:spPr>
           <a:xfrm>
-            <a:off x="7040880" y="4160520"/>
-            <a:ext cx="54864" cy="685800"/>
+            <a:off x="7040880" y="4114800"/>
+            <a:ext cx="54864" cy="594360"/>
           </a:xfrm>
           <a:prstGeom prst="rect">
             <a:avLst/>
@@ -23306,7 +24339,7 @@
         </p:nvSpPr>
         <p:spPr>
           <a:xfrm>
-            <a:off x="7205472" y="4233672"/>
+            <a:off x="7205472" y="4187952"/>
             <a:ext cx="4434840" cy="201168"/>
           </a:xfrm>
           <a:prstGeom prst="rect">
@@ -23345,8 +24378,8 @@
         </p:nvSpPr>
         <p:spPr>
           <a:xfrm>
-            <a:off x="7205472" y="4453128"/>
-            <a:ext cx="4434840" cy="365760"/>
+            <a:off x="7205472" y="4407408"/>
+            <a:ext cx="4434840" cy="274320"/>
           </a:xfrm>
           <a:prstGeom prst="rect">
             <a:avLst/>
@@ -23932,7 +24965,7 @@
                 </a:solidFill>
                 <a:latin typeface="Calibri"/>
               </a:rPr>
-              <a:t>06 / 15 · CONFIDENTIAL</a:t>
+              <a:t>06 / 17 · CONFIDENTIAL</a:t>
             </a:r>
           </a:p>
         </p:txBody>
@@ -25242,7 +26275,7 @@
         <p:spPr>
           <a:xfrm>
             <a:off x="7040880" y="3246120"/>
-            <a:ext cx="4663440" cy="822960"/>
+            <a:ext cx="4663440" cy="777240"/>
           </a:xfrm>
           <a:prstGeom prst="rect">
             <a:avLst/>
@@ -25286,7 +26319,7 @@
         <p:spPr>
           <a:xfrm>
             <a:off x="7040880" y="3246120"/>
-            <a:ext cx="54864" cy="822960"/>
+            <a:ext cx="54864" cy="777240"/>
           </a:xfrm>
           <a:prstGeom prst="rect">
             <a:avLst/>
@@ -25369,7 +26402,7 @@
         <p:spPr>
           <a:xfrm>
             <a:off x="7205472" y="3538728"/>
-            <a:ext cx="4434840" cy="502920"/>
+            <a:ext cx="4434840" cy="457200"/>
           </a:xfrm>
           <a:prstGeom prst="rect">
             <a:avLst/>
@@ -25407,8 +26440,8 @@
         </p:nvSpPr>
         <p:spPr>
           <a:xfrm>
-            <a:off x="7040880" y="4160520"/>
-            <a:ext cx="4663440" cy="685800"/>
+            <a:off x="7040880" y="4114800"/>
+            <a:ext cx="4663440" cy="594360"/>
           </a:xfrm>
           <a:prstGeom prst="rect">
             <a:avLst/>
@@ -25451,8 +26484,8 @@
         </p:nvSpPr>
         <p:spPr>
           <a:xfrm>
-            <a:off x="7040880" y="4160520"/>
-            <a:ext cx="54864" cy="685800"/>
+            <a:off x="7040880" y="4114800"/>
+            <a:ext cx="54864" cy="594360"/>
           </a:xfrm>
           <a:prstGeom prst="rect">
             <a:avLst/>
@@ -25495,7 +26528,7 @@
         </p:nvSpPr>
         <p:spPr>
           <a:xfrm>
-            <a:off x="7205472" y="4233672"/>
+            <a:off x="7205472" y="4187952"/>
             <a:ext cx="4434840" cy="201168"/>
           </a:xfrm>
           <a:prstGeom prst="rect">
@@ -25534,8 +26567,8 @@
         </p:nvSpPr>
         <p:spPr>
           <a:xfrm>
-            <a:off x="7205472" y="4453128"/>
-            <a:ext cx="4434840" cy="365760"/>
+            <a:off x="7205472" y="4407408"/>
+            <a:ext cx="4434840" cy="274320"/>
           </a:xfrm>
           <a:prstGeom prst="rect">
             <a:avLst/>
@@ -26121,7 +27154,7 @@
                 </a:solidFill>
                 <a:latin typeface="Calibri"/>
               </a:rPr>
-              <a:t>07 / 15 · CONFIDENTIAL</a:t>
+              <a:t>07 / 17 · CONFIDENTIAL</a:t>
             </a:r>
           </a:p>
         </p:txBody>
@@ -27431,7 +28464,7 @@
         <p:spPr>
           <a:xfrm>
             <a:off x="7040880" y="3246120"/>
-            <a:ext cx="4663440" cy="822960"/>
+            <a:ext cx="4663440" cy="777240"/>
           </a:xfrm>
           <a:prstGeom prst="rect">
             <a:avLst/>
@@ -27475,7 +28508,7 @@
         <p:spPr>
           <a:xfrm>
             <a:off x="7040880" y="3246120"/>
-            <a:ext cx="54864" cy="822960"/>
+            <a:ext cx="54864" cy="777240"/>
           </a:xfrm>
           <a:prstGeom prst="rect">
             <a:avLst/>
@@ -27558,7 +28591,7 @@
         <p:spPr>
           <a:xfrm>
             <a:off x="7205472" y="3538728"/>
-            <a:ext cx="4434840" cy="502920"/>
+            <a:ext cx="4434840" cy="457200"/>
           </a:xfrm>
           <a:prstGeom prst="rect">
             <a:avLst/>
@@ -27596,8 +28629,8 @@
         </p:nvSpPr>
         <p:spPr>
           <a:xfrm>
-            <a:off x="7040880" y="4160520"/>
-            <a:ext cx="4663440" cy="685800"/>
+            <a:off x="7040880" y="4114800"/>
+            <a:ext cx="4663440" cy="594360"/>
           </a:xfrm>
           <a:prstGeom prst="rect">
             <a:avLst/>
@@ -27640,8 +28673,8 @@
         </p:nvSpPr>
         <p:spPr>
           <a:xfrm>
-            <a:off x="7040880" y="4160520"/>
-            <a:ext cx="54864" cy="685800"/>
+            <a:off x="7040880" y="4114800"/>
+            <a:ext cx="54864" cy="594360"/>
           </a:xfrm>
           <a:prstGeom prst="rect">
             <a:avLst/>
@@ -27684,7 +28717,7 @@
         </p:nvSpPr>
         <p:spPr>
           <a:xfrm>
-            <a:off x="7205472" y="4233672"/>
+            <a:off x="7205472" y="4187952"/>
             <a:ext cx="4434840" cy="201168"/>
           </a:xfrm>
           <a:prstGeom prst="rect">
@@ -27723,8 +28756,8 @@
         </p:nvSpPr>
         <p:spPr>
           <a:xfrm>
-            <a:off x="7205472" y="4453128"/>
-            <a:ext cx="4434840" cy="365760"/>
+            <a:off x="7205472" y="4407408"/>
+            <a:ext cx="4434840" cy="274320"/>
           </a:xfrm>
           <a:prstGeom prst="rect">
             <a:avLst/>
@@ -28310,7 +29343,7 @@
                 </a:solidFill>
                 <a:latin typeface="Calibri"/>
               </a:rPr>
-              <a:t>08 / 15 · CONFIDENTIAL</a:t>
+              <a:t>08 / 17 · CONFIDENTIAL</a:t>
             </a:r>
           </a:p>
         </p:txBody>
@@ -29620,7 +30653,7 @@
         <p:spPr>
           <a:xfrm>
             <a:off x="7040880" y="3246120"/>
-            <a:ext cx="4663440" cy="822960"/>
+            <a:ext cx="4663440" cy="777240"/>
           </a:xfrm>
           <a:prstGeom prst="rect">
             <a:avLst/>
@@ -29664,7 +30697,7 @@
         <p:spPr>
           <a:xfrm>
             <a:off x="7040880" y="3246120"/>
-            <a:ext cx="54864" cy="822960"/>
+            <a:ext cx="54864" cy="777240"/>
           </a:xfrm>
           <a:prstGeom prst="rect">
             <a:avLst/>
@@ -29747,7 +30780,7 @@
         <p:spPr>
           <a:xfrm>
             <a:off x="7205472" y="3538728"/>
-            <a:ext cx="4434840" cy="502920"/>
+            <a:ext cx="4434840" cy="457200"/>
           </a:xfrm>
           <a:prstGeom prst="rect">
             <a:avLst/>
@@ -29785,8 +30818,8 @@
         </p:nvSpPr>
         <p:spPr>
           <a:xfrm>
-            <a:off x="7040880" y="4160520"/>
-            <a:ext cx="4663440" cy="685800"/>
+            <a:off x="7040880" y="4114800"/>
+            <a:ext cx="4663440" cy="594360"/>
           </a:xfrm>
           <a:prstGeom prst="rect">
             <a:avLst/>
@@ -29829,8 +30862,8 @@
         </p:nvSpPr>
         <p:spPr>
           <a:xfrm>
-            <a:off x="7040880" y="4160520"/>
-            <a:ext cx="54864" cy="685800"/>
+            <a:off x="7040880" y="4114800"/>
+            <a:ext cx="54864" cy="594360"/>
           </a:xfrm>
           <a:prstGeom prst="rect">
             <a:avLst/>
@@ -29873,7 +30906,7 @@
         </p:nvSpPr>
         <p:spPr>
           <a:xfrm>
-            <a:off x="7205472" y="4233672"/>
+            <a:off x="7205472" y="4187952"/>
             <a:ext cx="4434840" cy="201168"/>
           </a:xfrm>
           <a:prstGeom prst="rect">
@@ -29912,8 +30945,8 @@
         </p:nvSpPr>
         <p:spPr>
           <a:xfrm>
-            <a:off x="7205472" y="4453128"/>
-            <a:ext cx="4434840" cy="365760"/>
+            <a:off x="7205472" y="4407408"/>
+            <a:ext cx="4434840" cy="274320"/>
           </a:xfrm>
           <a:prstGeom prst="rect">
             <a:avLst/>
@@ -29946,6 +30979,172 @@
       <p:sp>
         <p:nvSpPr>
           <p:cNvPr id="40" name="Rectangle 39"/>
+          <p:cNvSpPr/>
+          <p:nvPr/>
+        </p:nvSpPr>
+        <p:spPr>
+          <a:xfrm>
+            <a:off x="7040880" y="4800600"/>
+            <a:ext cx="4663440" cy="411480"/>
+          </a:xfrm>
+          <a:prstGeom prst="rect">
+            <a:avLst/>
+          </a:prstGeom>
+          <a:solidFill>
+            <a:srgbClr val="ECFDF5"/>
+          </a:solidFill>
+          <a:ln>
+            <a:noFill/>
+          </a:ln>
+          <a:effectLst/>
+        </p:spPr>
+        <p:style>
+          <a:lnRef idx="1">
+            <a:schemeClr val="accent1"/>
+          </a:lnRef>
+          <a:fillRef idx="3">
+            <a:schemeClr val="accent1"/>
+          </a:fillRef>
+          <a:effectRef idx="2">
+            <a:schemeClr val="accent1"/>
+          </a:effectRef>
+          <a:fontRef idx="minor">
+            <a:schemeClr val="lt1"/>
+          </a:fontRef>
+        </p:style>
+        <p:txBody>
+          <a:bodyPr rtlCol="0" anchor="ctr"/>
+          <a:lstStyle/>
+          <a:p>
+            <a:pPr algn="ctr"/>
+          </a:p>
+        </p:txBody>
+      </p:sp>
+      <p:sp>
+        <p:nvSpPr>
+          <p:cNvPr id="41" name="Rectangle 40"/>
+          <p:cNvSpPr/>
+          <p:nvPr/>
+        </p:nvSpPr>
+        <p:spPr>
+          <a:xfrm>
+            <a:off x="7040880" y="4800600"/>
+            <a:ext cx="54864" cy="411480"/>
+          </a:xfrm>
+          <a:prstGeom prst="rect">
+            <a:avLst/>
+          </a:prstGeom>
+          <a:solidFill>
+            <a:srgbClr val="14A085"/>
+          </a:solidFill>
+          <a:ln>
+            <a:noFill/>
+          </a:ln>
+          <a:effectLst/>
+        </p:spPr>
+        <p:style>
+          <a:lnRef idx="1">
+            <a:schemeClr val="accent1"/>
+          </a:lnRef>
+          <a:fillRef idx="3">
+            <a:schemeClr val="accent1"/>
+          </a:fillRef>
+          <a:effectRef idx="2">
+            <a:schemeClr val="accent1"/>
+          </a:effectRef>
+          <a:fontRef idx="minor">
+            <a:schemeClr val="lt1"/>
+          </a:fontRef>
+        </p:style>
+        <p:txBody>
+          <a:bodyPr rtlCol="0" anchor="ctr"/>
+          <a:lstStyle/>
+          <a:p>
+            <a:pPr algn="ctr"/>
+          </a:p>
+        </p:txBody>
+      </p:sp>
+      <p:sp>
+        <p:nvSpPr>
+          <p:cNvPr id="42" name="TextBox 41"/>
+          <p:cNvSpPr txBox="1"/>
+          <p:nvPr/>
+        </p:nvSpPr>
+        <p:spPr>
+          <a:xfrm>
+            <a:off x="7178040" y="4818888"/>
+            <a:ext cx="4480560" cy="164592"/>
+          </a:xfrm>
+          <a:prstGeom prst="rect">
+            <a:avLst/>
+          </a:prstGeom>
+          <a:noFill/>
+        </p:spPr>
+        <p:txBody>
+          <a:bodyPr wrap="square" lIns="0" rIns="0" tIns="0" bIns="0" anchor="t">
+            <a:spAutoFit/>
+          </a:bodyPr>
+          <a:lstStyle/>
+          <a:p>
+            <a:pPr algn="l">
+              <a:lnSpc>
+                <a:spcPct val="120000"/>
+              </a:lnSpc>
+            </a:pPr>
+            <a:r>
+              <a:rPr sz="800" b="1" i="0">
+                <a:solidFill>
+                  <a:srgbClr val="0D8A72"/>
+                </a:solidFill>
+                <a:latin typeface="Calibri"/>
+              </a:rPr>
+              <a:t>RECOMMENDED HYUNDAI START</a:t>
+            </a:r>
+          </a:p>
+        </p:txBody>
+      </p:sp>
+      <p:sp>
+        <p:nvSpPr>
+          <p:cNvPr id="43" name="TextBox 42"/>
+          <p:cNvSpPr txBox="1"/>
+          <p:nvPr/>
+        </p:nvSpPr>
+        <p:spPr>
+          <a:xfrm>
+            <a:off x="7178040" y="4965192"/>
+            <a:ext cx="4480560" cy="246888"/>
+          </a:xfrm>
+          <a:prstGeom prst="rect">
+            <a:avLst/>
+          </a:prstGeom>
+          <a:noFill/>
+        </p:spPr>
+        <p:txBody>
+          <a:bodyPr wrap="square" lIns="0" rIns="0" tIns="0" bIns="0" anchor="t">
+            <a:spAutoFit/>
+          </a:bodyPr>
+          <a:lstStyle/>
+          <a:p>
+            <a:pPr algn="l">
+              <a:lnSpc>
+                <a:spcPct val="130000"/>
+              </a:lnSpc>
+            </a:pPr>
+            <a:r>
+              <a:rPr sz="850" b="0" i="0">
+                <a:solidFill>
+                  <a:srgbClr val="1E293B"/>
+                </a:solidFill>
+                <a:latin typeface="Calibri"/>
+              </a:rPr>
+              <a:t>Ulsan stamping presses + Asan welding cells — high-criticality assets where one unplanned hour ripples across the world's largest auto plant. 3–5 assets in pilot, scale to all critical lines on validation.</a:t>
+            </a:r>
+          </a:p>
+        </p:txBody>
+      </p:sp>
+      <p:sp>
+        <p:nvSpPr>
+          <p:cNvPr id="44" name="Rectangle 43"/>
           <p:cNvSpPr/>
           <p:nvPr/>
         </p:nvSpPr>
@@ -29989,7 +31188,7 @@
       </p:sp>
       <p:sp>
         <p:nvSpPr>
-          <p:cNvPr id="41" name="Rectangle 40"/>
+          <p:cNvPr id="45" name="Rectangle 44"/>
           <p:cNvSpPr/>
           <p:nvPr/>
         </p:nvSpPr>
@@ -30033,7 +31232,7 @@
       </p:sp>
       <p:sp>
         <p:nvSpPr>
-          <p:cNvPr id="42" name="TextBox 41"/>
+          <p:cNvPr id="46" name="TextBox 45"/>
           <p:cNvSpPr txBox="1"/>
           <p:nvPr/>
         </p:nvSpPr>
@@ -30072,7 +31271,7 @@
       </p:sp>
       <p:sp>
         <p:nvSpPr>
-          <p:cNvPr id="43" name="TextBox 42"/>
+          <p:cNvPr id="47" name="TextBox 46"/>
           <p:cNvSpPr txBox="1"/>
           <p:nvPr/>
         </p:nvSpPr>
@@ -30111,7 +31310,7 @@
       </p:sp>
       <p:sp>
         <p:nvSpPr>
-          <p:cNvPr id="44" name="TextBox 43"/>
+          <p:cNvPr id="48" name="TextBox 47"/>
           <p:cNvSpPr txBox="1"/>
           <p:nvPr/>
         </p:nvSpPr>
@@ -30150,7 +31349,7 @@
       </p:sp>
       <p:sp>
         <p:nvSpPr>
-          <p:cNvPr id="45" name="TextBox 44"/>
+          <p:cNvPr id="49" name="TextBox 48"/>
           <p:cNvSpPr txBox="1"/>
           <p:nvPr/>
         </p:nvSpPr>
@@ -30189,7 +31388,7 @@
       </p:sp>
       <p:sp>
         <p:nvSpPr>
-          <p:cNvPr id="46" name="TextBox 45"/>
+          <p:cNvPr id="50" name="TextBox 49"/>
           <p:cNvSpPr txBox="1"/>
           <p:nvPr/>
         </p:nvSpPr>
@@ -30228,7 +31427,7 @@
       </p:sp>
       <p:sp>
         <p:nvSpPr>
-          <p:cNvPr id="47" name="TextBox 46"/>
+          <p:cNvPr id="51" name="TextBox 50"/>
           <p:cNvSpPr txBox="1"/>
           <p:nvPr/>
         </p:nvSpPr>
@@ -30267,7 +31466,7 @@
       </p:sp>
       <p:sp>
         <p:nvSpPr>
-          <p:cNvPr id="48" name="TextBox 47"/>
+          <p:cNvPr id="52" name="TextBox 51"/>
           <p:cNvSpPr txBox="1"/>
           <p:nvPr/>
         </p:nvSpPr>
@@ -30306,7 +31505,7 @@
       </p:sp>
       <p:sp>
         <p:nvSpPr>
-          <p:cNvPr id="49" name="TextBox 48"/>
+          <p:cNvPr id="53" name="TextBox 52"/>
           <p:cNvSpPr txBox="1"/>
           <p:nvPr/>
         </p:nvSpPr>
@@ -30345,7 +31544,7 @@
       </p:sp>
       <p:sp>
         <p:nvSpPr>
-          <p:cNvPr id="50" name="TextBox 49"/>
+          <p:cNvPr id="54" name="TextBox 53"/>
           <p:cNvSpPr txBox="1"/>
           <p:nvPr/>
         </p:nvSpPr>
@@ -30384,7 +31583,7 @@
       </p:sp>
       <p:sp>
         <p:nvSpPr>
-          <p:cNvPr id="51" name="Rectangle 50"/>
+          <p:cNvPr id="55" name="Rectangle 54"/>
           <p:cNvSpPr/>
           <p:nvPr/>
         </p:nvSpPr>
@@ -30428,7 +31627,7 @@
       </p:sp>
       <p:sp>
         <p:nvSpPr>
-          <p:cNvPr id="52" name="TextBox 51"/>
+          <p:cNvPr id="56" name="TextBox 55"/>
           <p:cNvSpPr txBox="1"/>
           <p:nvPr/>
         </p:nvSpPr>
@@ -30467,7 +31666,7 @@
       </p:sp>
       <p:sp>
         <p:nvSpPr>
-          <p:cNvPr id="53" name="TextBox 52"/>
+          <p:cNvPr id="57" name="TextBox 56"/>
           <p:cNvSpPr txBox="1"/>
           <p:nvPr/>
         </p:nvSpPr>
@@ -30499,7 +31698,7 @@
                 </a:solidFill>
                 <a:latin typeface="Calibri"/>
               </a:rPr>
-              <a:t>09 / 15 · CONFIDENTIAL</a:t>
+              <a:t>09 / 17 · CONFIDENTIAL</a:t>
             </a:r>
           </a:p>
         </p:txBody>

</xml_diff>